<commit_message>
System Design 101 (vi): split the sd-08-008 library links, stop presenting a property as enforcement in sd-08-010
Co-Authored-By: Claude Sonnet 5.5 <noreply@anthropic.com>
Claude-Session: https://claude.ai/code/session_01DkN7YTqFfdjb8A8J5ehSWS
</commit_message>
<xml_diff>
--- a/system-design-101/vi/lessons/sd-08-010/slides/sd-08-010.pptx
+++ b/system-design-101/vi/lessons/sd-08-010/slides/sd-08-010.pptx
@@ -9478,6 +9478,17 @@
               <a:buChar char="•"/>
             </a:pPr>
             <a:r>
+              <a:rPr lang="en-US" sz="2550" dirty="0" spc="9" kern="0">
+                <a:solidFill>
+                  <a:srgbClr val="14161C"/>
+                </a:solidFill>
+                <a:latin typeface="Be Vietnam Pro" pitchFamily="34" charset="0"/>
+                <a:ea typeface="Be Vietnam Pro" pitchFamily="34" charset="-122"/>
+                <a:cs typeface="Be Vietnam Pro" pitchFamily="34" charset="-120"/>
+              </a:rPr>
+              <a:t>Python</a:t>
+            </a:r>
+            <a:r>
               <a:rPr lang="en-US" sz="2550" dirty="0" spc="1" kern="0">
                 <a:solidFill>
                   <a:srgbClr val="14161C"/>
@@ -9486,18 +9497,7 @@
                 <a:ea typeface="Be Vietnam Pro" pitchFamily="34" charset="-122"/>
                 <a:cs typeface="Be Vietnam Pro" pitchFamily="34" charset="-120"/>
               </a:rPr>
-              <a:t>Cần</a:t>
-            </a:r>
-            <a:r>
-              <a:rPr lang="en-US" sz="2550" dirty="0" spc="-9" kern="0">
-                <a:solidFill>
-                  <a:srgbClr val="14161C"/>
-                </a:solidFill>
-                <a:latin typeface="Be Vietnam Pro" pitchFamily="34" charset="0"/>
-                <a:ea typeface="Be Vietnam Pro" pitchFamily="34" charset="-122"/>
-                <a:cs typeface="Be Vietnam Pro" pitchFamily="34" charset="-120"/>
-              </a:rPr>
-              <a:t> chặt</a:t>
+              <a:t> không</a:t>
             </a:r>
             <a:r>
               <a:rPr lang="en-US" sz="2550" dirty="0" spc="0" kern="0">
@@ -9508,7 +9508,18 @@
                 <a:ea typeface="Be Vietnam Pro" pitchFamily="34" charset="-122"/>
                 <a:cs typeface="Be Vietnam Pro" pitchFamily="34" charset="-120"/>
               </a:rPr>
-              <a:t> hơn:</a:t>
+              <a:t> chặn</a:t>
+            </a:r>
+            <a:r>
+              <a:rPr lang="en-US" sz="2550" dirty="0" spc="6" kern="0">
+                <a:solidFill>
+                  <a:srgbClr val="14161C"/>
+                </a:solidFill>
+                <a:latin typeface="Be Vietnam Pro" pitchFamily="34" charset="0"/>
+                <a:ea typeface="Be Vietnam Pro" pitchFamily="34" charset="-122"/>
+                <a:cs typeface="Be Vietnam Pro" pitchFamily="34" charset="-120"/>
+              </a:rPr>
+              <a:t> được</a:t>
             </a:r>
             <a:r>
               <a:rPr lang="en-US" sz="2550" dirty="0" spc="-1" kern="0">
@@ -9519,7 +9530,18 @@
                 <a:ea typeface="Be Vietnam Pro" pitchFamily="34" charset="-122"/>
                 <a:cs typeface="Be Vietnam Pro" pitchFamily="34" charset="-120"/>
               </a:rPr>
-              <a:t> thuộc</a:t>
+              <a:t> ai</a:t>
+            </a:r>
+            <a:r>
+              <a:rPr lang="en-US" sz="2550" dirty="0" spc="0" kern="0">
+                <a:solidFill>
+                  <a:srgbClr val="14161C"/>
+                </a:solidFill>
+                <a:latin typeface="Be Vietnam Pro" pitchFamily="34" charset="0"/>
+                <a:ea typeface="Be Vietnam Pro" pitchFamily="34" charset="-122"/>
+                <a:cs typeface="Be Vietnam Pro" pitchFamily="34" charset="-120"/>
+              </a:rPr>
+              <a:t> cố</a:t>
             </a:r>
             <a:r>
               <a:rPr lang="en-US" sz="2550" dirty="0" spc="1" kern="0">
@@ -9530,29 +9552,84 @@
                 <a:ea typeface="Be Vietnam Pro" pitchFamily="34" charset="-122"/>
                 <a:cs typeface="Be Vietnam Pro" pitchFamily="34" charset="-120"/>
               </a:rPr>
-              <a:t> tính chỉ</a:t>
-            </a:r>
-            <a:r>
-              <a:rPr lang="en-US" sz="2550" dirty="0" spc="10" kern="0">
-                <a:solidFill>
-                  <a:srgbClr val="14161C"/>
-                </a:solidFill>
-                <a:latin typeface="Be Vietnam Pro" pitchFamily="34" charset="0"/>
-                <a:ea typeface="Be Vietnam Pro" pitchFamily="34" charset="-122"/>
-                <a:cs typeface="Be Vietnam Pro" pitchFamily="34" charset="-120"/>
-              </a:rPr>
-              <a:t> đọc</a:t>
-            </a:r>
-            <a:r>
-              <a:rPr lang="en-US" sz="2550" dirty="0" spc="-12" kern="0">
-                <a:solidFill>
-                  <a:srgbClr val="14161C"/>
-                </a:solidFill>
-                <a:latin typeface="Be Vietnam Pro" pitchFamily="34" charset="0"/>
-                <a:ea typeface="Be Vietnam Pro" pitchFamily="34" charset="-122"/>
-                <a:cs typeface="Be Vietnam Pro" pitchFamily="34" charset="-120"/>
-              </a:rPr>
-              <a:t> (property).</a:t>
+              <a:t> ghi:</a:t>
+            </a:r>
+            <a:r>
+              <a:rPr lang="en-US" sz="2550" dirty="0" spc="0" kern="0">
+                <a:solidFill>
+                  <a:srgbClr val="14161C"/>
+                </a:solidFill>
+                <a:latin typeface="Be Vietnam Pro" pitchFamily="34" charset="0"/>
+                <a:ea typeface="Be Vietnam Pro" pitchFamily="34" charset="-122"/>
+                <a:cs typeface="Be Vietnam Pro" pitchFamily="34" charset="-120"/>
+              </a:rPr>
+              <a:t> cần</a:t>
+            </a:r>
+            <a:r>
+              <a:rPr lang="en-US" sz="2550" dirty="0" spc="1" kern="0">
+                <a:solidFill>
+                  <a:srgbClr val="14161C"/>
+                </a:solidFill>
+                <a:latin typeface="Be Vietnam Pro" pitchFamily="34" charset="0"/>
+                <a:ea typeface="Be Vietnam Pro" pitchFamily="34" charset="-122"/>
+                <a:cs typeface="Be Vietnam Pro" pitchFamily="34" charset="-120"/>
+              </a:rPr>
+              <a:t> kiểm</a:t>
+            </a:r>
+            <a:r>
+              <a:rPr lang="en-US" sz="2550" dirty="0" spc="-1" kern="0">
+                <a:solidFill>
+                  <a:srgbClr val="14161C"/>
+                </a:solidFill>
+                <a:latin typeface="Be Vietnam Pro" pitchFamily="34" charset="0"/>
+                <a:ea typeface="Be Vietnam Pro" pitchFamily="34" charset="-122"/>
+                <a:cs typeface="Be Vietnam Pro" pitchFamily="34" charset="-120"/>
+              </a:rPr>
+              <a:t> thử</a:t>
+            </a:r>
+            <a:r>
+              <a:rPr lang="en-US" sz="2550" dirty="0" spc="-19" kern="0">
+                <a:solidFill>
+                  <a:srgbClr val="14161C"/>
+                </a:solidFill>
+                <a:latin typeface="Be Vietnam Pro" pitchFamily="34" charset="0"/>
+                <a:ea typeface="Be Vietnam Pro" pitchFamily="34" charset="-122"/>
+                <a:cs typeface="Be Vietnam Pro" pitchFamily="34" charset="-120"/>
+              </a:rPr>
+              <a:t> và</a:t>
+            </a:r>
+            <a:r>
+              <a:rPr lang="en-US" sz="2550" dirty="0" spc="-18" kern="0">
+                <a:solidFill>
+                  <a:srgbClr val="14161C"/>
+                </a:solidFill>
+                <a:latin typeface="Be Vietnam Pro" pitchFamily="34" charset="0"/>
+                <a:ea typeface="Be Vietnam Pro" pitchFamily="34" charset="-122"/>
+                <a:cs typeface="Be Vietnam Pro" pitchFamily="34" charset="-120"/>
+              </a:rPr>
+              <a:t> xem</a:t>
+            </a:r>
+            <a:r>
+              <a:rPr lang="en-US" sz="2550" dirty="0" spc="-24" kern="0">
+                <a:solidFill>
+                  <a:srgbClr val="14161C"/>
+                </a:solidFill>
+                <a:latin typeface="Be Vietnam Pro" pitchFamily="34" charset="0"/>
+                <a:ea typeface="Be Vietnam Pro" pitchFamily="34" charset="-122"/>
+                <a:cs typeface="Be Vietnam Pro" pitchFamily="34" charset="-120"/>
+              </a:rPr>
+              <a:t> xét</a:t>
+            </a:r>
+            <a:r>
+              <a:rPr lang="en-US" sz="2550" dirty="0" spc="2" kern="0">
+                <a:solidFill>
+                  <a:srgbClr val="14161C"/>
+                </a:solidFill>
+                <a:latin typeface="Be Vietnam Pro" pitchFamily="34" charset="0"/>
+                <a:ea typeface="Be Vietnam Pro" pitchFamily="34" charset="-122"/>
+                <a:cs typeface="Be Vietnam Pro" pitchFamily="34" charset="-120"/>
+              </a:rPr>
+              <a:t> mã.</a:t>
             </a:r>
             <a:endParaRPr lang="en-US" sz="2550" dirty="0"/>
           </a:p>

</xml_diff>